<commit_message>
fix(ppt): enlarge fonts + reposition elements per review (slides 2/3/5/9/11)
</commit_message>
<xml_diff>
--- a/docs/edge-aiops-submission.pptx
+++ b/docs/edge-aiops-submission.pptx
@@ -5418,7 +5418,7 @@
               </a:lnSpc>
             </a:pPr>
             <a:r>
-              <a:rPr sz="950" b="0" i="0">
+              <a:rPr sz="1200" b="0" i="0">
                 <a:solidFill>
                   <a:srgbClr val="FFFFFF"/>
                 </a:solidFill>
@@ -5427,7 +5427,7 @@
               <a:t>【输入】</a:t>
             </a:r>
             <a:r>
-              <a:rPr sz="950" b="0" i="0">
+              <a:rPr sz="1200" b="0" i="0">
                 <a:solidFill>
                   <a:srgbClr val="FFFFFF"/>
                 </a:solidFill>
@@ -5443,7 +5443,7 @@
               </a:lnSpc>
             </a:pPr>
             <a:r>
-              <a:rPr sz="950" b="0" i="0">
+              <a:rPr sz="1200" b="0" i="0">
                 <a:solidFill>
                   <a:srgbClr val="FFFFFF"/>
                 </a:solidFill>
@@ -5459,7 +5459,7 @@
               </a:lnSpc>
             </a:pPr>
             <a:r>
-              <a:rPr sz="950" b="0" i="0">
+              <a:rPr sz="1200" b="0" i="0">
                 <a:solidFill>
                   <a:srgbClr val="FFFFFF"/>
                 </a:solidFill>
@@ -5468,7 +5468,7 @@
               <a:t>【输出】</a:t>
             </a:r>
             <a:r>
-              <a:rPr sz="950" b="0" i="0">
+              <a:rPr sz="1200" b="0" i="0">
                 <a:solidFill>
                   <a:srgbClr val="FFFFFF"/>
                 </a:solidFill>
@@ -5484,7 +5484,7 @@
               </a:lnSpc>
             </a:pPr>
             <a:r>
-              <a:rPr sz="950" b="0" i="0">
+              <a:rPr sz="1200" b="0" i="0">
                 <a:solidFill>
                   <a:srgbClr val="FFFFFF"/>
                 </a:solidFill>
@@ -5500,7 +5500,7 @@
               </a:lnSpc>
             </a:pPr>
             <a:r>
-              <a:rPr sz="950" b="0" i="0">
+              <a:rPr sz="1200" b="0" i="0">
                 <a:solidFill>
                   <a:srgbClr val="FFFFFF"/>
                 </a:solidFill>
@@ -5509,7 +5509,7 @@
               <a:t>【依赖】</a:t>
             </a:r>
             <a:r>
-              <a:rPr sz="950" b="0" i="0">
+              <a:rPr sz="1200" b="0" i="0">
                 <a:solidFill>
                   <a:srgbClr val="FFFFFF"/>
                 </a:solidFill>
@@ -5525,7 +5525,7 @@
               </a:lnSpc>
             </a:pPr>
             <a:r>
-              <a:rPr sz="950" b="0" i="0">
+              <a:rPr sz="1200" b="0" i="0">
                 <a:solidFill>
                   <a:srgbClr val="FFFFFF"/>
                 </a:solidFill>
@@ -5534,7 +5534,7 @@
               <a:t>【失败】解析失败</a:t>
             </a:r>
             <a:r>
-              <a:rPr sz="950" b="0" i="0">
+              <a:rPr sz="1200" b="0" i="0">
                 <a:solidFill>
                   <a:srgbClr val="FFFFFF"/>
                 </a:solidFill>
@@ -5543,7 +5543,7 @@
               <a:t>/</a:t>
             </a:r>
             <a:r>
-              <a:rPr sz="950" b="0" i="0">
+              <a:rPr sz="1200" b="0" i="0">
                 <a:solidFill>
                   <a:srgbClr val="FFFFFF"/>
                 </a:solidFill>
@@ -5552,7 +5552,7 @@
               <a:t>未知</a:t>
             </a:r>
             <a:r>
-              <a:rPr sz="950" b="0" i="0">
+              <a:rPr sz="1200" b="0" i="0">
                 <a:solidFill>
                   <a:srgbClr val="FFFFFF"/>
                 </a:solidFill>
@@ -5561,7 +5561,7 @@
               <a:t> action → </a:t>
             </a:r>
             <a:r>
-              <a:rPr sz="950" b="0" i="0">
+              <a:rPr sz="1200" b="0" i="0">
                 <a:solidFill>
                   <a:srgbClr val="FFFFFF"/>
                 </a:solidFill>
@@ -5570,7 +5570,7 @@
               <a:t>一律返回</a:t>
             </a:r>
             <a:r>
-              <a:rPr sz="950" b="0" i="0">
+              <a:rPr sz="1200" b="0" i="0">
                 <a:solidFill>
                   <a:srgbClr val="FFFFFF"/>
                 </a:solidFill>
@@ -5728,7 +5728,7 @@
               </a:lnSpc>
             </a:pPr>
             <a:r>
-              <a:rPr sz="1000" b="0" i="0">
+              <a:rPr sz="1200" b="0" i="0">
                 <a:solidFill>
                   <a:srgbClr val="1F2228"/>
                 </a:solidFill>
@@ -5737,7 +5737,7 @@
               <a:t>· alert-fusion: 多类信号 → 事故候选</a:t>
             </a:r>
             <a:r>
-              <a:rPr sz="1000" b="0" i="0">
+              <a:rPr sz="1200" b="0" i="0">
                 <a:solidFill>
                   <a:srgbClr val="1F2228"/>
                 </a:solidFill>
@@ -5746,7 +5746,7 @@
               <a:t/>
             </a:r>
             <a:r>
-              <a:rPr sz="1000" b="0" i="0">
+              <a:rPr sz="1200" b="0" i="0">
                 <a:solidFill>
                   <a:srgbClr val="1F2228"/>
                 </a:solidFill>
@@ -5755,7 +5755,7 @@
               <a:t/>
             </a:r>
             <a:r>
-              <a:rPr sz="1000" b="0" i="0">
+              <a:rPr sz="1200" b="0" i="0">
                 <a:solidFill>
                   <a:srgbClr val="1F2228"/>
                 </a:solidFill>
@@ -5794,7 +5794,7 @@
               </a:lnSpc>
             </a:pPr>
             <a:r>
-              <a:rPr sz="1000" b="0" i="0">
+              <a:rPr sz="1200" b="0" i="0">
                 <a:solidFill>
                   <a:srgbClr val="1F2228"/>
                 </a:solidFill>
@@ -5803,7 +5803,7 @@
               <a:t>· impact-mapping: 事故 → 节点+SLO 影响</a:t>
             </a:r>
             <a:r>
-              <a:rPr sz="1000" b="0" i="0">
+              <a:rPr sz="1200" b="0" i="0">
                 <a:solidFill>
                   <a:srgbClr val="1F2228"/>
                 </a:solidFill>
@@ -5812,7 +5812,7 @@
               <a:t/>
             </a:r>
             <a:r>
-              <a:rPr sz="1000" b="0" i="0">
+              <a:rPr sz="1200" b="0" i="0">
                 <a:solidFill>
                   <a:srgbClr val="1F2228"/>
                 </a:solidFill>
@@ -5821,7 +5821,7 @@
               <a:t/>
             </a:r>
             <a:r>
-              <a:rPr sz="1000" b="0" i="0">
+              <a:rPr sz="1200" b="0" i="0">
                 <a:solidFill>
                   <a:srgbClr val="1F2228"/>
                 </a:solidFill>
@@ -5860,7 +5860,7 @@
               </a:lnSpc>
             </a:pPr>
             <a:r>
-              <a:rPr sz="1000" b="0" i="0">
+              <a:rPr sz="1200" b="0" i="0">
                 <a:solidFill>
                   <a:srgbClr val="1F2228"/>
                 </a:solidFill>
@@ -5869,7 +5869,7 @@
               <a:t>· log-trace-rca: 多源证据 → top_candidate</a:t>
             </a:r>
             <a:r>
-              <a:rPr sz="1000" b="0" i="0">
+              <a:rPr sz="1200" b="0" i="0">
                 <a:solidFill>
                   <a:srgbClr val="1F2228"/>
                 </a:solidFill>
@@ -5878,7 +5878,7 @@
               <a:t/>
             </a:r>
             <a:r>
-              <a:rPr sz="1000" b="0" i="0">
+              <a:rPr sz="1200" b="0" i="0">
                 <a:solidFill>
                   <a:srgbClr val="1F2228"/>
                 </a:solidFill>
@@ -5887,7 +5887,7 @@
               <a:t/>
             </a:r>
             <a:r>
-              <a:rPr sz="1000" b="0" i="0">
+              <a:rPr sz="1200" b="0" i="0">
                 <a:solidFill>
                   <a:srgbClr val="1F2228"/>
                 </a:solidFill>
@@ -5926,7 +5926,7 @@
               </a:lnSpc>
             </a:pPr>
             <a:r>
-              <a:rPr sz="1000" b="0" i="0">
+              <a:rPr sz="1200" b="0" i="0">
                 <a:solidFill>
                   <a:srgbClr val="1F2228"/>
                 </a:solidFill>
@@ -5935,7 +5935,7 @@
               <a:t>· remediation-plan: RCA → 风险分级方案</a:t>
             </a:r>
             <a:r>
-              <a:rPr sz="1000" b="0" i="0">
+              <a:rPr sz="1200" b="0" i="0">
                 <a:solidFill>
                   <a:srgbClr val="1F2228"/>
                 </a:solidFill>
@@ -5944,7 +5944,7 @@
               <a:t/>
             </a:r>
             <a:r>
-              <a:rPr sz="1000" b="0" i="0">
+              <a:rPr sz="1200" b="0" i="0">
                 <a:solidFill>
                   <a:srgbClr val="1F2228"/>
                 </a:solidFill>
@@ -5953,7 +5953,7 @@
               <a:t/>
             </a:r>
             <a:r>
-              <a:rPr sz="1000" b="0" i="0">
+              <a:rPr sz="1200" b="0" i="0">
                 <a:solidFill>
                   <a:srgbClr val="1F2228"/>
                 </a:solidFill>
@@ -5962,7 +5962,7 @@
               <a:t/>
             </a:r>
             <a:r>
-              <a:rPr sz="1000" b="0" i="0">
+              <a:rPr sz="1200" b="0" i="0">
                 <a:solidFill>
                   <a:srgbClr val="1F2228"/>
                 </a:solidFill>
@@ -5971,7 +5971,7 @@
               <a:t/>
             </a:r>
             <a:r>
-              <a:rPr sz="1000" b="0" i="0">
+              <a:rPr sz="1200" b="0" i="0">
                 <a:solidFill>
                   <a:srgbClr val="1F2228"/>
                 </a:solidFill>
@@ -6010,7 +6010,7 @@
               </a:lnSpc>
             </a:pPr>
             <a:r>
-              <a:rPr sz="1000" b="0" i="0">
+              <a:rPr sz="1200" b="0" i="0">
                 <a:solidFill>
                   <a:srgbClr val="1F2228"/>
                 </a:solidFill>
@@ -6019,7 +6019,7 @@
               <a:t>· model-governance: 模型回归/漂移分类</a:t>
             </a:r>
             <a:r>
-              <a:rPr sz="1000" b="0" i="0">
+              <a:rPr sz="1200" b="0" i="0">
                 <a:solidFill>
                   <a:srgbClr val="1F2228"/>
                 </a:solidFill>
@@ -6028,7 +6028,7 @@
               <a:t/>
             </a:r>
             <a:r>
-              <a:rPr sz="1000" b="0" i="0">
+              <a:rPr sz="1200" b="0" i="0">
                 <a:solidFill>
                   <a:srgbClr val="1F2228"/>
                 </a:solidFill>
@@ -6037,7 +6037,7 @@
               <a:t/>
             </a:r>
             <a:r>
-              <a:rPr sz="1000" b="0" i="0">
+              <a:rPr sz="1200" b="0" i="0">
                 <a:solidFill>
                   <a:srgbClr val="1F2228"/>
                 </a:solidFill>
@@ -6076,7 +6076,7 @@
               </a:lnSpc>
             </a:pPr>
             <a:r>
-              <a:rPr sz="1000" b="0" i="0">
+              <a:rPr sz="1200" b="0" i="0">
                 <a:solidFill>
                   <a:srgbClr val="1F2228"/>
                 </a:solidFill>
@@ -6085,7 +6085,7 @@
               <a:t>· recovery-verify: SLA + 队列状态验证</a:t>
             </a:r>
             <a:r>
-              <a:rPr sz="1000" b="0" i="0">
+              <a:rPr sz="1200" b="0" i="0">
                 <a:solidFill>
                   <a:srgbClr val="1F2228"/>
                 </a:solidFill>
@@ -6094,7 +6094,7 @@
               <a:t/>
             </a:r>
             <a:r>
-              <a:rPr sz="1000" b="0" i="0">
+              <a:rPr sz="1200" b="0" i="0">
                 <a:solidFill>
                   <a:srgbClr val="1F2228"/>
                 </a:solidFill>
@@ -6103,7 +6103,7 @@
               <a:t/>
             </a:r>
             <a:r>
-              <a:rPr sz="1000" b="0" i="0">
+              <a:rPr sz="1200" b="0" i="0">
                 <a:solidFill>
                   <a:srgbClr val="1F2228"/>
                 </a:solidFill>
@@ -16244,7 +16244,7 @@
         </p:nvSpPr>
         <p:spPr>
           <a:xfrm>
-            <a:off x="594360" y="1965960"/>
+            <a:off x="594360" y="1280160"/>
             <a:ext cx="3484778" cy="1554480"/>
           </a:xfrm>
           <a:prstGeom prst="roundRect">
@@ -16269,7 +16269,7 @@
         </p:nvSpPr>
         <p:spPr>
           <a:xfrm>
-            <a:off x="850392" y="2221992"/>
+            <a:off x="850392" y="1280160"/>
             <a:ext cx="146304" cy="146304"/>
           </a:xfrm>
           <a:prstGeom prst="ellipse">
@@ -16292,7 +16292,7 @@
         </p:nvSpPr>
         <p:spPr>
           <a:xfrm>
-            <a:off x="1097280" y="2130552"/>
+            <a:off x="1097280" y="1417320"/>
             <a:ext cx="2798978" cy="329184"/>
           </a:xfrm>
           <a:prstGeom prst="rect">
@@ -16308,7 +16308,7 @@
               <a:buNone/>
             </a:pPr>
             <a:r>
-              <a:rPr lang="en-US" sz="1500" b="1" dirty="0">
+              <a:rPr lang="en-US" sz="1800" b="1" dirty="0">
                 <a:solidFill>
                   <a:srgbClr val="1B1F3B"/>
                 </a:solidFill>
@@ -16330,8 +16330,8 @@
         </p:nvSpPr>
         <p:spPr>
           <a:xfrm>
-            <a:off x="850392" y="3063240"/>
-            <a:ext cx="3027578" cy="347472"/>
+            <a:off x="850392" y="2423160"/>
+            <a:ext cx="3027578" cy="1005840"/>
           </a:xfrm>
           <a:prstGeom prst="rect">
             <a:avLst/>
@@ -16346,7 +16346,7 @@
               <a:buNone/>
             </a:pPr>
             <a:r>
-              <a:rPr sz="1050" b="0" i="0">
+              <a:rPr sz="1400" b="0" i="0">
                 <a:solidFill>
                   <a:srgbClr val="1F2228"/>
                 </a:solidFill>
@@ -16358,7 +16358,7 @@
           </a:p>
           <a:p>
             <a:r>
-              <a:rPr sz="1050" b="0" i="0">
+              <a:rPr sz="1400" b="0" i="0">
                 <a:solidFill>
                   <a:srgbClr val="1F2228"/>
                 </a:solidFill>
@@ -16367,7 +16367,7 @@
               <a:t>智能运维</a:t>
             </a:r>
             <a:r>
-              <a:rPr sz="1050" b="0" i="0">
+              <a:rPr sz="1400" b="0" i="0">
                 <a:solidFill>
                   <a:srgbClr val="1F2228"/>
                 </a:solidFill>
@@ -16386,7 +16386,7 @@
         </p:nvSpPr>
         <p:spPr>
           <a:xfrm>
-            <a:off x="4353458" y="1965960"/>
+            <a:off x="4353458" y="1280160"/>
             <a:ext cx="3484778" cy="1554480"/>
           </a:xfrm>
           <a:prstGeom prst="roundRect">
@@ -16411,7 +16411,7 @@
         </p:nvSpPr>
         <p:spPr>
           <a:xfrm>
-            <a:off x="4609490" y="2221992"/>
+            <a:off x="4609490" y="1280160"/>
             <a:ext cx="146304" cy="146304"/>
           </a:xfrm>
           <a:prstGeom prst="ellipse">
@@ -16434,7 +16434,7 @@
         </p:nvSpPr>
         <p:spPr>
           <a:xfrm>
-            <a:off x="4856378" y="2130552"/>
+            <a:off x="4856378" y="1417320"/>
             <a:ext cx="2798978" cy="329184"/>
           </a:xfrm>
           <a:prstGeom prst="rect">
@@ -16450,7 +16450,7 @@
               <a:buNone/>
             </a:pPr>
             <a:r>
-              <a:rPr lang="en-US" sz="1500" b="1" dirty="0">
+              <a:rPr lang="en-US" sz="1800" b="1" dirty="0">
                 <a:solidFill>
                   <a:srgbClr val="1B1F3B"/>
                 </a:solidFill>
@@ -16472,8 +16472,8 @@
         </p:nvSpPr>
         <p:spPr>
           <a:xfrm>
-            <a:off x="4609490" y="3063240"/>
-            <a:ext cx="3027578" cy="347472"/>
+            <a:off x="4609490" y="2423160"/>
+            <a:ext cx="3027578" cy="1005840"/>
           </a:xfrm>
           <a:prstGeom prst="rect">
             <a:avLst/>
@@ -16488,72 +16488,72 @@
               <a:buNone/>
             </a:pPr>
             <a:r>
-              <a:rPr sz="1050" b="0" i="0">
+              <a:rPr sz="1400" b="0" i="0">
                 <a:solidFill>
                   <a:srgbClr val="1F2228"/>
                 </a:solidFill>
                 <a:latin typeface="宋体"/>
               </a:rPr>
-              <a:t>面向云上应用</a:t>
-            </a:r>
-            <a:r>
-              <a:rPr sz="1050" b="0" i="0">
+              <a:t>面向边缘 AI / SRE 团队</a:t>
+            </a:r>
+            <a:r>
+              <a:rPr sz="1400" b="0" i="0">
                 <a:solidFill>
                   <a:srgbClr val="1F2228"/>
                 </a:solidFill>
                 <a:latin typeface="Times New Roman"/>
               </a:rPr>
-              <a:t> / SRE </a:t>
-            </a:r>
-            <a:r>
-              <a:rPr sz="1050" b="0" i="0">
+              <a:t/>
+            </a:r>
+            <a:r>
+              <a:rPr sz="1400" b="0" i="0">
                 <a:solidFill>
                   <a:srgbClr val="1F2228"/>
                 </a:solidFill>
                 <a:latin typeface="宋体"/>
               </a:rPr>
-              <a:t>团队</a:t>
+              <a:t/>
             </a:r>
             <a:endParaRPr lang="en-US" sz="1050" dirty="0"/>
           </a:p>
           <a:p>
             <a:r>
-              <a:rPr sz="1050" b="0" i="0">
+              <a:rPr sz="1400" b="0" i="0">
                 <a:solidFill>
                   <a:srgbClr val="1F2228"/>
                 </a:solidFill>
                 <a:latin typeface="宋体"/>
               </a:rPr>
-              <a:t>故障需人工翻日志、查</a:t>
-            </a:r>
-            <a:r>
-              <a:rPr sz="1050" b="0" i="0">
+              <a:t>事故需人工翻日志、查 Trace、审配置</a:t>
+            </a:r>
+            <a:r>
+              <a:rPr sz="1400" b="0" i="0">
                 <a:solidFill>
                   <a:srgbClr val="1F2228"/>
                 </a:solidFill>
                 <a:latin typeface="Times New Roman"/>
               </a:rPr>
-              <a:t> Trace</a:t>
-            </a:r>
-            <a:r>
-              <a:rPr sz="1050" b="0" i="0">
+              <a:t/>
+            </a:r>
+            <a:r>
+              <a:rPr sz="1400" b="0" i="0">
                 <a:solidFill>
                   <a:srgbClr val="1F2228"/>
                 </a:solidFill>
                 <a:latin typeface="宋体"/>
               </a:rPr>
-              <a:t>、审配置</a:t>
-            </a:r>
-          </a:p>
-          <a:p>
-            <a:r>
-              <a:rPr sz="1050" b="0" i="0">
+              <a:t/>
+            </a:r>
+          </a:p>
+          <a:p>
+            <a:r>
+              <a:rPr sz="1400" b="0" i="0">
                 <a:solidFill>
                   <a:srgbClr val="1F2228"/>
                 </a:solidFill>
                 <a:latin typeface="宋体"/>
               </a:rPr>
-              <a:t>恢复慢且依赖资深经验</a:t>
+              <a:t>OTA 回归靠资深经验恢复</a:t>
             </a:r>
           </a:p>
         </p:txBody>
@@ -16566,7 +16566,7 @@
         </p:nvSpPr>
         <p:spPr>
           <a:xfrm>
-            <a:off x="8112557" y="1965960"/>
+            <a:off x="8112557" y="1280160"/>
             <a:ext cx="3484778" cy="1554480"/>
           </a:xfrm>
           <a:prstGeom prst="roundRect">
@@ -16591,7 +16591,7 @@
         </p:nvSpPr>
         <p:spPr>
           <a:xfrm>
-            <a:off x="8368589" y="2221992"/>
+            <a:off x="8368589" y="1280160"/>
             <a:ext cx="146304" cy="146304"/>
           </a:xfrm>
           <a:prstGeom prst="ellipse">
@@ -16614,7 +16614,7 @@
         </p:nvSpPr>
         <p:spPr>
           <a:xfrm>
-            <a:off x="8615477" y="2130552"/>
+            <a:off x="8615477" y="1417320"/>
             <a:ext cx="2798978" cy="329184"/>
           </a:xfrm>
           <a:prstGeom prst="rect">
@@ -16630,7 +16630,7 @@
               <a:buNone/>
             </a:pPr>
             <a:r>
-              <a:rPr lang="en-US" sz="1500" b="1" dirty="0">
+              <a:rPr lang="en-US" sz="1800" b="1" dirty="0">
                 <a:solidFill>
                   <a:srgbClr val="1B1F3B"/>
                 </a:solidFill>
@@ -16652,8 +16652,8 @@
         </p:nvSpPr>
         <p:spPr>
           <a:xfrm>
-            <a:off x="8368589" y="3063240"/>
-            <a:ext cx="3027578" cy="347472"/>
+            <a:off x="8368589" y="2423160"/>
+            <a:ext cx="3027578" cy="1005840"/>
           </a:xfrm>
           <a:prstGeom prst="rect">
             <a:avLst/>
@@ -16668,126 +16668,127 @@
               <a:buNone/>
             </a:pPr>
             <a:r>
-              <a:rPr sz="1050" b="0" i="0">
+              <a:rPr sz="1400" b="0" i="0">
                 <a:solidFill>
                   <a:srgbClr val="1F2228"/>
                 </a:solidFill>
                 <a:latin typeface="宋体"/>
               </a:rPr>
-              <a:t>多</a:t>
-            </a:r>
-            <a:r>
-              <a:rPr sz="1050" b="0" i="0">
+              <a:t>4 职能 Agent + 7 决策 Skill + 工具网关</a:t>
+            </a:r>
+            <a:r>
+              <a:rPr sz="1400" b="0" i="0">
                 <a:solidFill>
                   <a:srgbClr val="1F2228"/>
                 </a:solidFill>
                 <a:latin typeface="Times New Roman"/>
               </a:rPr>
-              <a:t> Agent + Skill + </a:t>
-            </a:r>
-            <a:r>
-              <a:rPr sz="1050" b="0" i="0">
+              <a:t/>
+            </a:r>
+            <a:r>
+              <a:rPr sz="1400" b="0" i="0">
                 <a:solidFill>
                   <a:srgbClr val="1F2228"/>
                 </a:solidFill>
                 <a:latin typeface="宋体"/>
               </a:rPr>
-              <a:t>工具网关</a:t>
+              <a:t/>
             </a:r>
             <a:endParaRPr lang="en-US" sz="1050" dirty="0"/>
           </a:p>
           <a:p>
             <a:r>
-              <a:rPr sz="1050" b="0" i="0">
+              <a:rPr sz="1400" b="0" i="0">
                 <a:solidFill>
                   <a:srgbClr val="1F2228"/>
                 </a:solidFill>
                 <a:latin typeface="宋体"/>
               </a:rPr>
-              <a:t>告警</a:t>
-            </a:r>
-            <a:r>
-              <a:rPr sz="1050" b="0" i="0">
+              <a:t>检测→归因→规划→验证 零人工闭环</a:t>
+            </a:r>
+            <a:r>
+              <a:rPr sz="1400" b="0" i="0">
                 <a:solidFill>
                   <a:srgbClr val="1F2228"/>
                 </a:solidFill>
                 <a:latin typeface="Times New Roman"/>
               </a:rPr>
-              <a:t>→</a:t>
-            </a:r>
-            <a:r>
-              <a:rPr sz="1050" b="0" i="0">
+              <a:t/>
+            </a:r>
+            <a:r>
+              <a:rPr sz="1400" b="0" i="0">
                 <a:solidFill>
                   <a:srgbClr val="1F2228"/>
                 </a:solidFill>
                 <a:latin typeface="宋体"/>
               </a:rPr>
-              <a:t>根因</a:t>
-            </a:r>
-            <a:r>
-              <a:rPr sz="1050" b="0" i="0">
+              <a:t/>
+            </a:r>
+            <a:r>
+              <a:rPr sz="1400" b="0" i="0">
                 <a:solidFill>
                   <a:srgbClr val="1F2228"/>
                 </a:solidFill>
                 <a:latin typeface="Times New Roman"/>
               </a:rPr>
-              <a:t>→</a:t>
-            </a:r>
-            <a:r>
-              <a:rPr sz="1050" b="0" i="0">
+              <a:t/>
+            </a:r>
+            <a:r>
+              <a:rPr sz="1400" b="0" i="0">
                 <a:solidFill>
                   <a:srgbClr val="1F2228"/>
                 </a:solidFill>
                 <a:latin typeface="宋体"/>
               </a:rPr>
-              <a:t>修复</a:t>
-            </a:r>
-            <a:r>
-              <a:rPr sz="1050" b="0" i="0">
+              <a:t/>
+            </a:r>
+            <a:r>
+              <a:rPr sz="1400" b="0" i="0">
                 <a:solidFill>
                   <a:srgbClr val="1F2228"/>
                 </a:solidFill>
                 <a:latin typeface="Times New Roman"/>
               </a:rPr>
-              <a:t>→</a:t>
-            </a:r>
-            <a:r>
-              <a:rPr sz="1050" b="0" i="0">
+              <a:t/>
+            </a:r>
+            <a:r>
+              <a:rPr sz="1400" b="0" i="0">
                 <a:solidFill>
                   <a:srgbClr val="1F2228"/>
                 </a:solidFill>
                 <a:latin typeface="宋体"/>
               </a:rPr>
-              <a:t>验证</a:t>
-            </a:r>
-            <a:r>
-              <a:rPr sz="1050" b="0" i="0">
+              <a:t/>
+            </a:r>
+            <a:r>
+              <a:rPr sz="1400" b="0" i="0">
                 <a:solidFill>
                   <a:srgbClr val="1F2228"/>
                 </a:solidFill>
                 <a:latin typeface="Times New Roman"/>
               </a:rPr>
-              <a:t> </a:t>
-            </a:r>
-            <a:r>
-              <a:rPr sz="1050" b="0" i="0">
+              <a:t/>
+            </a:r>
+            <a:r>
+              <a:rPr sz="1400" b="0" i="0">
                 <a:solidFill>
                   <a:srgbClr val="1F2228"/>
                 </a:solidFill>
                 <a:latin typeface="宋体"/>
               </a:rPr>
-              <a:t>零人工闭环</a:t>
-            </a:r>
-          </a:p>
-          <a:p>
-            <a:r>
-              <a:rPr sz="1050" b="0" i="0">
+              <a:t/>
+            </a:r>
+          </a:p>
+          <a:p>
+            <a:r>
+              <a:rPr sz="1400" b="0" i="0">
                 <a:solidFill>
                   <a:srgbClr val="1F2228"/>
                 </a:solidFill>
                 <a:latin typeface="宋体"/>
               </a:rPr>
-              <a:t>低风险自动执行，高风险审批</a:t>
+              <a:t>agents-decide / operators-execute
+HITL seam 做 L2/L3 审批</a:t>
             </a:r>
           </a:p>
         </p:txBody>
@@ -16800,7 +16801,7 @@
         </p:nvSpPr>
         <p:spPr>
           <a:xfrm>
-            <a:off x="594360" y="3776472"/>
+            <a:off x="594360" y="3566160"/>
             <a:ext cx="3484778" cy="1554480"/>
           </a:xfrm>
           <a:prstGeom prst="roundRect">
@@ -16825,7 +16826,7 @@
         </p:nvSpPr>
         <p:spPr>
           <a:xfrm>
-            <a:off x="850392" y="4032504"/>
+            <a:off x="850392" y="3566160"/>
             <a:ext cx="146304" cy="146304"/>
           </a:xfrm>
           <a:prstGeom prst="ellipse">
@@ -16848,7 +16849,7 @@
         </p:nvSpPr>
         <p:spPr>
           <a:xfrm>
-            <a:off x="1097280" y="3941064"/>
+            <a:off x="1097280" y="3703320"/>
             <a:ext cx="2798978" cy="329184"/>
           </a:xfrm>
           <a:prstGeom prst="rect">
@@ -16864,7 +16865,7 @@
               <a:buNone/>
             </a:pPr>
             <a:r>
-              <a:rPr lang="en-US" sz="1500" b="1" dirty="0">
+              <a:rPr lang="en-US" sz="1800" b="1" dirty="0">
                 <a:solidFill>
                   <a:srgbClr val="1B1F3B"/>
                 </a:solidFill>
@@ -16886,8 +16887,8 @@
         </p:nvSpPr>
         <p:spPr>
           <a:xfrm>
-            <a:off x="850392" y="4873752"/>
-            <a:ext cx="3027578" cy="347472"/>
+            <a:off x="850392" y="4709160"/>
+            <a:ext cx="3027578" cy="1005840"/>
           </a:xfrm>
           <a:prstGeom prst="rect">
             <a:avLst/>
@@ -16902,37 +16903,37 @@
               <a:buNone/>
             </a:pPr>
             <a:r>
-              <a:rPr sz="1050" b="0" i="0">
+              <a:rPr sz="1400" b="0" i="0">
                 <a:solidFill>
                   <a:srgbClr val="1F2228"/>
                 </a:solidFill>
                 <a:latin typeface="Times New Roman"/>
               </a:rPr>
-              <a:t>4 </a:t>
-            </a:r>
-            <a:r>
-              <a:rPr sz="1050" b="0" i="0">
+              <a:t>4 LLM Agent + TeamLeader + Manager</a:t>
+            </a:r>
+            <a:r>
+              <a:rPr sz="1400" b="0" i="0">
                 <a:solidFill>
                   <a:srgbClr val="1F2228"/>
                 </a:solidFill>
                 <a:latin typeface="宋体"/>
               </a:rPr>
-              <a:t>个</a:t>
-            </a:r>
-            <a:r>
-              <a:rPr sz="1050" b="0" i="0">
+              <a:t/>
+            </a:r>
+            <a:r>
+              <a:rPr sz="1400" b="0" i="0">
                 <a:solidFill>
                   <a:srgbClr val="1F2228"/>
                 </a:solidFill>
                 <a:latin typeface="Times New Roman"/>
               </a:rPr>
-              <a:t> LLM Agent + TeamLeader</a:t>
+              <a:t/>
             </a:r>
             <a:endParaRPr lang="en-US" sz="1050" dirty="0"/>
           </a:p>
           <a:p>
             <a:r>
-              <a:rPr sz="1050" b="0" i="0">
+              <a:rPr sz="1400" b="0" i="0">
                 <a:solidFill>
                   <a:srgbClr val="1F2228"/>
                 </a:solidFill>
@@ -16943,31 +16944,32 @@
           </a:p>
           <a:p>
             <a:r>
-              <a:rPr sz="1050" b="0" i="0">
+              <a:rPr sz="1400" b="0" i="0">
                 <a:solidFill>
                   <a:srgbClr val="1F2228"/>
                 </a:solidFill>
                 <a:latin typeface="宋体"/>
               </a:rPr>
-              <a:t>内置</a:t>
-            </a:r>
-            <a:r>
-              <a:rPr sz="1050" b="0" i="0">
+              <a:t>内置 L0-L3 风险分级
+mock 与真协议 1:1 对齐</a:t>
+            </a:r>
+            <a:r>
+              <a:rPr sz="1400" b="0" i="0">
                 <a:solidFill>
                   <a:srgbClr val="1F2228"/>
                 </a:solidFill>
                 <a:latin typeface="Times New Roman"/>
               </a:rPr>
-              <a:t> L0-L3 </a:t>
-            </a:r>
-            <a:r>
-              <a:rPr sz="1050" b="0" i="0">
+              <a:t/>
+            </a:r>
+            <a:r>
+              <a:rPr sz="1400" b="0" i="0">
                 <a:solidFill>
                   <a:srgbClr val="1F2228"/>
                 </a:solidFill>
                 <a:latin typeface="宋体"/>
               </a:rPr>
-              <a:t>风险分级</a:t>
+              <a:t/>
             </a:r>
           </a:p>
         </p:txBody>
@@ -16980,7 +16982,7 @@
         </p:nvSpPr>
         <p:spPr>
           <a:xfrm>
-            <a:off x="4353458" y="3776472"/>
+            <a:off x="4353458" y="3566160"/>
             <a:ext cx="3484778" cy="1554480"/>
           </a:xfrm>
           <a:prstGeom prst="roundRect">
@@ -17005,7 +17007,7 @@
         </p:nvSpPr>
         <p:spPr>
           <a:xfrm>
-            <a:off x="4609490" y="4032504"/>
+            <a:off x="4609490" y="3566160"/>
             <a:ext cx="146304" cy="146304"/>
           </a:xfrm>
           <a:prstGeom prst="ellipse">
@@ -17028,7 +17030,7 @@
         </p:nvSpPr>
         <p:spPr>
           <a:xfrm>
-            <a:off x="4856378" y="3941064"/>
+            <a:off x="4856378" y="3703320"/>
             <a:ext cx="2798978" cy="329184"/>
           </a:xfrm>
           <a:prstGeom prst="rect">
@@ -17044,7 +17046,7 @@
               <a:buNone/>
             </a:pPr>
             <a:r>
-              <a:rPr lang="en-US" sz="1500" b="1" dirty="0">
+              <a:rPr lang="en-US" sz="1800" b="1" dirty="0">
                 <a:solidFill>
                   <a:srgbClr val="1B1F3B"/>
                 </a:solidFill>
@@ -17066,8 +17068,8 @@
         </p:nvSpPr>
         <p:spPr>
           <a:xfrm>
-            <a:off x="4609490" y="4873752"/>
-            <a:ext cx="3027578" cy="347472"/>
+            <a:off x="4609490" y="4709160"/>
+            <a:ext cx="3027578" cy="1005840"/>
           </a:xfrm>
           <a:prstGeom prst="rect">
             <a:avLst/>
@@ -17082,7 +17084,7 @@
               <a:buNone/>
             </a:pPr>
             <a:r>
-              <a:rPr sz="1050" b="0" i="0">
+              <a:rPr sz="1400" b="0" i="0">
                 <a:solidFill>
                   <a:srgbClr val="1F2228"/>
                 </a:solidFill>
@@ -17091,7 +17093,7 @@
               <a:t>7 个 Skill + 11 类工具契约</a:t>
             </a:r>
             <a:r>
-              <a:rPr sz="1050" b="0" i="0">
+              <a:rPr sz="1400" b="0" i="0">
                 <a:solidFill>
                   <a:srgbClr val="1F2228"/>
                 </a:solidFill>
@@ -17100,7 +17102,7 @@
               <a:t/>
             </a:r>
             <a:r>
-              <a:rPr sz="1050" b="0" i="0">
+              <a:rPr sz="1400" b="0" i="0">
                 <a:solidFill>
                   <a:srgbClr val="1F2228"/>
                 </a:solidFill>
@@ -17109,7 +17111,7 @@
               <a:t/>
             </a:r>
             <a:r>
-              <a:rPr sz="1050" b="0" i="0">
+              <a:rPr sz="1400" b="0" i="0">
                 <a:solidFill>
                   <a:srgbClr val="1F2228"/>
                 </a:solidFill>
@@ -17121,7 +17123,7 @@
           </a:p>
           <a:p>
             <a:r>
-              <a:rPr sz="1050" b="0" i="0">
+              <a:rPr sz="1400" b="0" i="0">
                 <a:solidFill>
                   <a:srgbClr val="1F2228"/>
                 </a:solidFill>
@@ -17130,7 +17132,7 @@
               <a:t>可发布到</a:t>
             </a:r>
             <a:r>
-              <a:rPr sz="1050" b="0" i="0">
+              <a:rPr sz="1400" b="0" i="0">
                 <a:solidFill>
                   <a:srgbClr val="1F2228"/>
                 </a:solidFill>
@@ -17141,7 +17143,7 @@
           </a:p>
           <a:p>
             <a:r>
-              <a:rPr sz="1050" b="0" i="0">
+              <a:rPr sz="1400" b="0" i="0">
                 <a:solidFill>
                   <a:srgbClr val="1F2228"/>
                 </a:solidFill>
@@ -17150,7 +17152,7 @@
               <a:t>平滑升级</a:t>
             </a:r>
             <a:r>
-              <a:rPr sz="1050" b="0" i="0">
+              <a:rPr sz="1400" b="0" i="0">
                 <a:solidFill>
                   <a:srgbClr val="1F2228"/>
                 </a:solidFill>
@@ -17169,7 +17171,7 @@
         </p:nvSpPr>
         <p:spPr>
           <a:xfrm>
-            <a:off x="8112557" y="3776472"/>
+            <a:off x="8112557" y="3566160"/>
             <a:ext cx="3484778" cy="1554480"/>
           </a:xfrm>
           <a:prstGeom prst="roundRect">
@@ -17194,7 +17196,7 @@
         </p:nvSpPr>
         <p:spPr>
           <a:xfrm>
-            <a:off x="8368589" y="4032504"/>
+            <a:off x="8368589" y="3566160"/>
             <a:ext cx="146304" cy="146304"/>
           </a:xfrm>
           <a:prstGeom prst="ellipse">
@@ -17217,7 +17219,7 @@
         </p:nvSpPr>
         <p:spPr>
           <a:xfrm>
-            <a:off x="8615477" y="3941064"/>
+            <a:off x="8615477" y="3703320"/>
             <a:ext cx="2798978" cy="329184"/>
           </a:xfrm>
           <a:prstGeom prst="rect">
@@ -17233,7 +17235,7 @@
               <a:buNone/>
             </a:pPr>
             <a:r>
-              <a:rPr lang="en-US" sz="1500" b="1" dirty="0">
+              <a:rPr lang="en-US" sz="1800" b="1" dirty="0">
                 <a:solidFill>
                   <a:srgbClr val="1B1F3B"/>
                 </a:solidFill>
@@ -17255,8 +17257,8 @@
         </p:nvSpPr>
         <p:spPr>
           <a:xfrm>
-            <a:off x="8368589" y="4873752"/>
-            <a:ext cx="3027578" cy="347472"/>
+            <a:off x="8368589" y="4709160"/>
+            <a:ext cx="3027578" cy="1005840"/>
           </a:xfrm>
           <a:prstGeom prst="rect">
             <a:avLst/>
@@ -17271,81 +17273,81 @@
               <a:buNone/>
             </a:pPr>
             <a:r>
-              <a:rPr sz="1050" b="0" i="0">
+              <a:rPr sz="1400" b="0" i="0">
                 <a:solidFill>
                   <a:srgbClr val="1F2228"/>
                 </a:solidFill>
                 <a:latin typeface="Times New Roman"/>
               </a:rPr>
-              <a:t>2 </a:t>
-            </a:r>
-            <a:r>
-              <a:rPr sz="1050" b="0" i="0">
+              <a:t>2 个 Edge AIOps 事故闭环：</a:t>
+            </a:r>
+            <a:r>
+              <a:rPr sz="1400" b="0" i="0">
                 <a:solidFill>
                   <a:srgbClr val="1F2228"/>
                 </a:solidFill>
                 <a:latin typeface="宋体"/>
               </a:rPr>
-              <a:t>个生产事故闭环：</a:t>
+              <a:t/>
             </a:r>
             <a:endParaRPr lang="en-US" sz="1050" dirty="0"/>
           </a:p>
           <a:p>
             <a:r>
-              <a:rPr sz="1050" b="0" i="0">
+              <a:rPr sz="1400" b="0" i="0">
                 <a:solidFill>
                   <a:srgbClr val="1F2228"/>
                 </a:solidFill>
                 <a:latin typeface="宋体"/>
               </a:rPr>
-              <a:t>连接池耗尽</a:t>
-            </a:r>
-            <a:r>
-              <a:rPr sz="1050" b="0" i="0">
+              <a:t>OTA 模型回归 + 边缘节点故障</a:t>
+            </a:r>
+            <a:r>
+              <a:rPr sz="1400" b="0" i="0">
                 <a:solidFill>
                   <a:srgbClr val="1F2228"/>
                 </a:solidFill>
                 <a:latin typeface="Times New Roman"/>
               </a:rPr>
-              <a:t> + </a:t>
-            </a:r>
-            <a:r>
-              <a:rPr sz="1050" b="0" i="0">
+              <a:t/>
+            </a:r>
+            <a:r>
+              <a:rPr sz="1400" b="0" i="0">
                 <a:solidFill>
                   <a:srgbClr val="1F2228"/>
                 </a:solidFill>
                 <a:latin typeface="宋体"/>
               </a:rPr>
-              <a:t>慢</a:t>
-            </a:r>
-            <a:r>
-              <a:rPr sz="1050" b="0" i="0">
+              <a:t/>
+            </a:r>
+            <a:r>
+              <a:rPr sz="1400" b="0" i="0">
                 <a:solidFill>
                   <a:srgbClr val="1F2228"/>
                 </a:solidFill>
                 <a:latin typeface="Times New Roman"/>
               </a:rPr>
-              <a:t> SQL </a:t>
-            </a:r>
-            <a:r>
-              <a:rPr sz="1050" b="0" i="0">
+              <a:t/>
+            </a:r>
+            <a:r>
+              <a:rPr sz="1400" b="0" i="0">
                 <a:solidFill>
                   <a:srgbClr val="1F2228"/>
                 </a:solidFill>
                 <a:latin typeface="宋体"/>
               </a:rPr>
-              <a:t>劣化</a:t>
-            </a:r>
-          </a:p>
-          <a:p>
-            <a:r>
-              <a:rPr sz="1050" b="0" i="0">
+              <a:t/>
+            </a:r>
+          </a:p>
+          <a:p>
+            <a:r>
+              <a:rPr sz="1400" b="0" i="0">
                 <a:solidFill>
                   <a:srgbClr val="1F2228"/>
                 </a:solidFill>
                 <a:latin typeface="宋体"/>
               </a:rPr>
-              <a:t>结构化事故报告</a:t>
+              <a:t>结构化事故报告 + 4 周落地 roadmap</a:t>
             </a:r>
           </a:p>
         </p:txBody>
@@ -18428,7 +18430,7 @@
                 <a:ea typeface="微软雅黑" pitchFamily="34" charset="-122"/>
                 <a:cs typeface="微软雅黑" pitchFamily="34" charset="-120"/>
               </a:rPr>
-              <a:t>Skills</a:t>
+              <a:t>Skill 工程体系</a:t>
             </a:r>
             <a:r>
               <a:rPr lang="zh-CN" altLang="en-US" sz="1250" dirty="0">
@@ -18568,7 +18570,7 @@
                 <a:ea typeface="微软雅黑" pitchFamily="34" charset="-122"/>
                 <a:cs typeface="微软雅黑" pitchFamily="34" charset="-120"/>
               </a:rPr>
-              <a:t>Demo</a:t>
+              <a:t>团队介绍</a:t>
             </a:r>
             <a:r>
               <a:rPr lang="zh-CN" altLang="en-US" sz="1250" dirty="0">
@@ -19829,8 +19831,8 @@
         </p:nvSpPr>
         <p:spPr>
           <a:xfrm>
-            <a:off x="731519" y="3535679"/>
-            <a:ext cx="5120639" cy="2316479"/>
+            <a:off x="731519" y="3246120"/>
+            <a:ext cx="5120639" cy="2194560"/>
           </a:xfrm>
           <a:prstGeom prst="rect">
             <a:avLst/>
@@ -19849,7 +19851,7 @@
               </a:lnSpc>
             </a:pPr>
             <a:r>
-              <a:rPr sz="1050" b="0" i="0">
+              <a:rPr sz="1300" b="0" i="0">
                 <a:solidFill>
                   <a:srgbClr val="FFFFFF"/>
                 </a:solidFill>
@@ -19858,7 +19860,7 @@
               <a:t>OTA 把 resnet50 v3.2.1 推到杭州集群（无 canary）</a:t>
             </a:r>
             <a:r>
-              <a:rPr sz="1050" b="0" i="0">
+              <a:rPr sz="1300" b="0" i="0">
                 <a:solidFill>
                   <a:srgbClr val="FFFFFF"/>
                 </a:solidFill>
@@ -19867,7 +19869,7 @@
               <a:t/>
             </a:r>
             <a:r>
-              <a:rPr sz="1050" b="0" i="0">
+              <a:rPr sz="1300" b="0" i="0">
                 <a:solidFill>
                   <a:srgbClr val="FFFFFF"/>
                 </a:solidFill>
@@ -19883,7 +19885,7 @@
               </a:lnSpc>
             </a:pPr>
             <a:r>
-              <a:rPr sz="1050" b="0" i="0">
+              <a:rPr sz="1300" b="0" i="0">
                 <a:solidFill>
                   <a:srgbClr val="FFFFFF"/>
                 </a:solidFill>
@@ -19892,7 +19894,7 @@
               <a:t>accuracy 0.92 → 0.71 / p99 420 → 1450ms</a:t>
             </a:r>
             <a:r>
-              <a:rPr sz="1050" b="0" i="0">
+              <a:rPr sz="1300" b="0" i="0">
                 <a:solidFill>
                   <a:srgbClr val="FFFFFF"/>
                 </a:solidFill>
@@ -19901,7 +19903,7 @@
               <a:t/>
             </a:r>
             <a:r>
-              <a:rPr sz="1050" b="0" i="0">
+              <a:rPr sz="1300" b="0" i="0">
                 <a:solidFill>
                   <a:srgbClr val="FFFFFF"/>
                 </a:solidFill>
@@ -19910,7 +19912,7 @@
               <a:t/>
             </a:r>
             <a:r>
-              <a:rPr sz="1050" b="0" i="0">
+              <a:rPr sz="1300" b="0" i="0">
                 <a:solidFill>
                   <a:srgbClr val="FFFFFF"/>
                 </a:solidFill>
@@ -19933,7 +19935,7 @@
               </a:lnSpc>
             </a:pPr>
             <a:r>
-              <a:rPr sz="1050" b="0" i="0">
+              <a:rPr sz="1300" b="0" i="0">
                 <a:solidFill>
                   <a:srgbClr val="FFFFFF"/>
                 </a:solidFill>
@@ -19942,7 +19944,7 @@
               <a:t>Agent 自动：归并告警 → 多源归因</a:t>
             </a:r>
             <a:r>
-              <a:rPr sz="1050" b="0" i="0">
+              <a:rPr sz="1300" b="0" i="0">
                 <a:solidFill>
                   <a:srgbClr val="FFFFFF"/>
                 </a:solidFill>
@@ -19951,7 +19953,7 @@
               <a:t/>
             </a:r>
             <a:r>
-              <a:rPr sz="1050" b="0" i="0">
+              <a:rPr sz="1300" b="0" i="0">
                 <a:solidFill>
                   <a:srgbClr val="FFFFFF"/>
                 </a:solidFill>
@@ -19960,7 +19962,7 @@
               <a:t/>
             </a:r>
             <a:r>
-              <a:rPr sz="1050" b="0" i="0">
+              <a:rPr sz="1300" b="0" i="0">
                 <a:solidFill>
                   <a:srgbClr val="FFFFFF"/>
                 </a:solidFill>
@@ -19976,7 +19978,7 @@
               </a:lnSpc>
             </a:pPr>
             <a:r>
-              <a:rPr sz="1050" b="0" i="0">
+              <a:rPr sz="1300" b="0" i="0">
                 <a:solidFill>
                   <a:srgbClr val="FFFFFF"/>
                 </a:solidFill>
@@ -19985,7 +19987,7 @@
               <a:t>→ quarantine_node L1 + rollback_model L2 待审</a:t>
             </a:r>
             <a:r>
-              <a:rPr sz="1050" b="0" i="0">
+              <a:rPr sz="1300" b="0" i="0">
                 <a:solidFill>
                   <a:srgbClr val="FFFFFF"/>
                 </a:solidFill>
@@ -19994,7 +19996,7 @@
               <a:t/>
             </a:r>
             <a:r>
-              <a:rPr sz="1050" b="0" i="0">
+              <a:rPr sz="1300" b="0" i="0">
                 <a:solidFill>
                   <a:srgbClr val="FFFFFF"/>
                 </a:solidFill>
@@ -20003,7 +20005,7 @@
               <a:t/>
             </a:r>
             <a:r>
-              <a:rPr sz="1050" b="0" i="0">
+              <a:rPr sz="1300" b="0" i="0">
                 <a:solidFill>
                   <a:srgbClr val="FFFFFF"/>
                 </a:solidFill>
@@ -20026,7 +20028,7 @@
               </a:lnSpc>
             </a:pPr>
             <a:r>
-              <a:rPr sz="1050" b="0" i="0">
+              <a:rPr sz="1300" b="0" i="0">
                 <a:solidFill>
                   <a:srgbClr val="FFFFFF"/>
                 </a:solidFill>
@@ -20035,7 +20037,7 @@
               <a:t>结果：accuracy 0.91 / p99 420ms / fleet healthy</a:t>
             </a:r>
             <a:r>
-              <a:rPr sz="1050" b="0" i="0">
+              <a:rPr sz="1300" b="0" i="0">
                 <a:solidFill>
                   <a:srgbClr val="FFFFFF"/>
                 </a:solidFill>
@@ -20203,8 +20205,8 @@
         </p:nvSpPr>
         <p:spPr>
           <a:xfrm>
-            <a:off x="6400799" y="3535679"/>
-            <a:ext cx="5120639" cy="2316479"/>
+            <a:off x="6400799" y="3246120"/>
+            <a:ext cx="5120639" cy="2194560"/>
           </a:xfrm>
           <a:prstGeom prst="rect">
             <a:avLst/>
@@ -20223,7 +20225,7 @@
               </a:lnSpc>
             </a:pPr>
             <a:r>
-              <a:rPr sz="1050" b="0" i="0">
+              <a:rPr sz="1300" b="0" i="0">
                 <a:solidFill>
                   <a:srgbClr val="FFFFFF"/>
                 </a:solidFill>
@@ -20232,7 +20234,7 @@
               <a:t>edge-shanghai-02 不可达 + edge-shanghai-05 GPU 热临界</a:t>
             </a:r>
             <a:r>
-              <a:rPr sz="1050" b="0" i="0">
+              <a:rPr sz="1300" b="0" i="0">
                 <a:solidFill>
                   <a:srgbClr val="FFFFFF"/>
                 </a:solidFill>
@@ -20241,7 +20243,7 @@
               <a:t/>
             </a:r>
             <a:r>
-              <a:rPr sz="1050" b="0" i="0">
+              <a:rPr sz="1300" b="0" i="0">
                 <a:solidFill>
                   <a:srgbClr val="FFFFFF"/>
                 </a:solidFill>
@@ -20250,7 +20252,7 @@
               <a:t/>
             </a:r>
             <a:r>
-              <a:rPr sz="1050" b="0" i="0">
+              <a:rPr sz="1300" b="0" i="0">
                 <a:solidFill>
                   <a:srgbClr val="FFFFFF"/>
                 </a:solidFill>
@@ -20266,7 +20268,7 @@
               </a:lnSpc>
             </a:pPr>
             <a:r>
-              <a:rPr sz="1050" b="0" i="0">
+              <a:rPr sz="1300" b="0" i="0">
                 <a:solidFill>
                   <a:srgbClr val="FFFFFF"/>
                 </a:solidFill>
@@ -20275,7 +20277,7 @@
               <a:t>throughput 12 qps / latency 1850ms</a:t>
             </a:r>
             <a:r>
-              <a:rPr sz="1050" b="0" i="0">
+              <a:rPr sz="1300" b="0" i="0">
                 <a:solidFill>
                   <a:srgbClr val="FFFFFF"/>
                 </a:solidFill>
@@ -20284,7 +20286,7 @@
               <a:t/>
             </a:r>
             <a:r>
-              <a:rPr sz="1050" b="0" i="0">
+              <a:rPr sz="1300" b="0" i="0">
                 <a:solidFill>
                   <a:srgbClr val="FFFFFF"/>
                 </a:solidFill>
@@ -20293,7 +20295,7 @@
               <a:t/>
             </a:r>
             <a:r>
-              <a:rPr sz="1050" b="0" i="0">
+              <a:rPr sz="1300" b="0" i="0">
                 <a:solidFill>
                   <a:srgbClr val="FFFFFF"/>
                 </a:solidFill>
@@ -20302,7 +20304,7 @@
               <a:t/>
             </a:r>
             <a:r>
-              <a:rPr sz="1050" b="0" i="0">
+              <a:rPr sz="1300" b="0" i="0">
                 <a:solidFill>
                   <a:srgbClr val="FFFFFF"/>
                 </a:solidFill>
@@ -20325,7 +20327,7 @@
               </a:lnSpc>
             </a:pPr>
             <a:r>
-              <a:rPr sz="1050" b="0" i="0">
+              <a:rPr sz="1300" b="0" i="0">
                 <a:solidFill>
                   <a:srgbClr val="FFFFFF"/>
                 </a:solidFill>
@@ -20334,7 +20336,7 @@
               <a:t>Agent 自动：多源归因</a:t>
             </a:r>
             <a:r>
-              <a:rPr sz="1050" b="0" i="0">
+              <a:rPr sz="1300" b="0" i="0">
                 <a:solidFill>
                   <a:srgbClr val="FFFFFF"/>
                 </a:solidFill>
@@ -20343,7 +20345,7 @@
               <a:t/>
             </a:r>
             <a:r>
-              <a:rPr sz="1050" b="0" i="0">
+              <a:rPr sz="1300" b="0" i="0">
                 <a:solidFill>
                   <a:srgbClr val="FFFFFF"/>
                 </a:solidFill>
@@ -20359,7 +20361,7 @@
               </a:lnSpc>
             </a:pPr>
             <a:r>
-              <a:rPr sz="1050" b="0" i="0">
+              <a:rPr sz="1300" b="0" i="0">
                 <a:solidFill>
                   <a:srgbClr val="FFFFFF"/>
                 </a:solidFill>
@@ -20368,7 +20370,7 @@
               <a:t>→ quarantine_node + throttle</a:t>
             </a:r>
             <a:r>
-              <a:rPr sz="1050" b="0" i="0">
+              <a:rPr sz="1300" b="0" i="0">
                 <a:solidFill>
                   <a:srgbClr val="FFFFFF"/>
                 </a:solidFill>
@@ -20384,7 +20386,7 @@
               </a:lnSpc>
             </a:pPr>
             <a:r>
-              <a:rPr sz="1050" b="0" i="0">
+              <a:rPr sz="1300" b="0" i="0">
                 <a:solidFill>
                   <a:srgbClr val="FFFFFF"/>
                 </a:solidFill>
@@ -20393,7 +20395,7 @@
               <a:t>→ verify 端点恢复</a:t>
             </a:r>
             <a:r>
-              <a:rPr sz="1050" b="0" i="0">
+              <a:rPr sz="1300" b="0" i="0">
                 <a:solidFill>
                   <a:srgbClr val="FFFFFF"/>
                 </a:solidFill>
@@ -20416,7 +20418,7 @@
               </a:lnSpc>
             </a:pPr>
             <a:r>
-              <a:rPr sz="1050" b="0" i="0">
+              <a:rPr sz="1300" b="0" i="0">
                 <a:solidFill>
                   <a:srgbClr val="FFFFFF"/>
                 </a:solidFill>
@@ -20425,7 +20427,7 @@
               <a:t>结果：fleet healthy / SLO 达标</a:t>
             </a:r>
             <a:r>
-              <a:rPr sz="1050" b="0" i="0">
+              <a:rPr sz="1300" b="0" i="0">
                 <a:solidFill>
                   <a:srgbClr val="FFFFFF"/>
                 </a:solidFill>
@@ -20434,7 +20436,7 @@
               <a:t/>
             </a:r>
             <a:r>
-              <a:rPr sz="1050" b="0" i="0">
+              <a:rPr sz="1300" b="0" i="0">
                 <a:solidFill>
                   <a:srgbClr val="FFFFFF"/>
                 </a:solidFill>
@@ -20443,7 +20445,7 @@
               <a:t/>
             </a:r>
             <a:r>
-              <a:rPr sz="1050" b="0" i="0">
+              <a:rPr sz="1300" b="0" i="0">
                 <a:solidFill>
                   <a:srgbClr val="FFFFFF"/>
                 </a:solidFill>
@@ -20462,7 +20464,7 @@
         </p:nvSpPr>
         <p:spPr>
           <a:xfrm>
-            <a:off x="487679" y="6095999"/>
+            <a:off x="487679" y="5026151"/>
             <a:ext cx="3535679" cy="1219199"/>
           </a:xfrm>
           <a:prstGeom prst="rect">
@@ -20506,7 +20508,7 @@
         </p:nvSpPr>
         <p:spPr>
           <a:xfrm>
-            <a:off x="609599" y="6156959"/>
+            <a:off x="609599" y="5087111"/>
             <a:ext cx="2194559" cy="731519"/>
           </a:xfrm>
           <a:prstGeom prst="rect">
@@ -20545,7 +20547,7 @@
         </p:nvSpPr>
         <p:spPr>
           <a:xfrm>
-            <a:off x="609599" y="6766559"/>
+            <a:off x="609599" y="5696711"/>
             <a:ext cx="2194559" cy="487679"/>
           </a:xfrm>
           <a:prstGeom prst="rect">
@@ -20584,7 +20586,7 @@
         </p:nvSpPr>
         <p:spPr>
           <a:xfrm>
-            <a:off x="2804159" y="6156959"/>
+            <a:off x="2804159" y="5087111"/>
             <a:ext cx="48767" cy="1097279"/>
           </a:xfrm>
           <a:prstGeom prst="rect">
@@ -20628,7 +20630,7 @@
         </p:nvSpPr>
         <p:spPr>
           <a:xfrm>
-            <a:off x="2926079" y="6278879"/>
+            <a:off x="2926079" y="5209031"/>
             <a:ext cx="1036319" cy="853439"/>
           </a:xfrm>
           <a:prstGeom prst="rect">
@@ -20676,7 +20678,7 @@
         </p:nvSpPr>
         <p:spPr>
           <a:xfrm>
-            <a:off x="4267199" y="6095999"/>
+            <a:off x="4267199" y="5026151"/>
             <a:ext cx="3535679" cy="1219199"/>
           </a:xfrm>
           <a:prstGeom prst="rect">
@@ -20720,7 +20722,7 @@
         </p:nvSpPr>
         <p:spPr>
           <a:xfrm>
-            <a:off x="4389119" y="6156959"/>
+            <a:off x="4389119" y="5087111"/>
             <a:ext cx="2194559" cy="731519"/>
           </a:xfrm>
           <a:prstGeom prst="rect">
@@ -20759,7 +20761,7 @@
         </p:nvSpPr>
         <p:spPr>
           <a:xfrm>
-            <a:off x="4389119" y="6766559"/>
+            <a:off x="4389119" y="5696711"/>
             <a:ext cx="2194559" cy="487679"/>
           </a:xfrm>
           <a:prstGeom prst="rect">
@@ -20798,7 +20800,7 @@
         </p:nvSpPr>
         <p:spPr>
           <a:xfrm>
-            <a:off x="6583679" y="6156959"/>
+            <a:off x="6583679" y="5087111"/>
             <a:ext cx="48767" cy="1097279"/>
           </a:xfrm>
           <a:prstGeom prst="rect">
@@ -20842,7 +20844,7 @@
         </p:nvSpPr>
         <p:spPr>
           <a:xfrm>
-            <a:off x="6705599" y="6278879"/>
+            <a:off x="6705599" y="5209031"/>
             <a:ext cx="1036319" cy="853439"/>
           </a:xfrm>
           <a:prstGeom prst="rect">
@@ -20890,7 +20892,7 @@
         </p:nvSpPr>
         <p:spPr>
           <a:xfrm>
-            <a:off x="8046719" y="6095999"/>
+            <a:off x="8046719" y="5026151"/>
             <a:ext cx="3535679" cy="1219199"/>
           </a:xfrm>
           <a:prstGeom prst="rect">
@@ -20934,7 +20936,7 @@
         </p:nvSpPr>
         <p:spPr>
           <a:xfrm>
-            <a:off x="8168639" y="6156959"/>
+            <a:off x="8168639" y="5087111"/>
             <a:ext cx="2194559" cy="731519"/>
           </a:xfrm>
           <a:prstGeom prst="rect">
@@ -20973,7 +20975,7 @@
         </p:nvSpPr>
         <p:spPr>
           <a:xfrm>
-            <a:off x="8168639" y="6766559"/>
+            <a:off x="8168639" y="5696711"/>
             <a:ext cx="2194559" cy="487679"/>
           </a:xfrm>
           <a:prstGeom prst="rect">
@@ -21012,7 +21014,7 @@
         </p:nvSpPr>
         <p:spPr>
           <a:xfrm>
-            <a:off x="10363199" y="6156959"/>
+            <a:off x="10363199" y="5087111"/>
             <a:ext cx="48767" cy="1097279"/>
           </a:xfrm>
           <a:prstGeom prst="rect">
@@ -21056,7 +21058,7 @@
         </p:nvSpPr>
         <p:spPr>
           <a:xfrm>
-            <a:off x="10485119" y="6278879"/>
+            <a:off x="10485119" y="5209031"/>
             <a:ext cx="1036319" cy="853439"/>
           </a:xfrm>
           <a:prstGeom prst="rect">
@@ -25639,7 +25641,7 @@
               </a:lnSpc>
             </a:pPr>
             <a:r>
-              <a:rPr sz="1000" b="0" i="0">
+              <a:rPr sz="1200" b="0" i="0">
                 <a:solidFill>
                   <a:srgbClr val="CCD3E0"/>
                 </a:solidFill>
@@ -25655,7 +25657,7 @@
               </a:lnSpc>
             </a:pPr>
             <a:r>
-              <a:rPr sz="1000" b="0" i="0">
+              <a:rPr sz="1200" b="0" i="0">
                 <a:solidFill>
                   <a:srgbClr val="CCD3E0"/>
                 </a:solidFill>
@@ -25671,7 +25673,7 @@
               </a:lnSpc>
             </a:pPr>
             <a:r>
-              <a:rPr sz="1000" b="0" i="0">
+              <a:rPr sz="1200" b="0" i="0">
                 <a:solidFill>
                   <a:srgbClr val="CCD3E0"/>
                 </a:solidFill>
@@ -25832,7 +25834,7 @@
               </a:lnSpc>
             </a:pPr>
             <a:r>
-              <a:rPr sz="1000" b="0" i="0">
+              <a:rPr sz="1200" b="0" i="0">
                 <a:solidFill>
                   <a:srgbClr val="CCD3E0"/>
                 </a:solidFill>
@@ -25848,7 +25850,7 @@
               </a:lnSpc>
             </a:pPr>
             <a:r>
-              <a:rPr sz="1000" b="0" i="0">
+              <a:rPr sz="1200" b="0" i="0">
                 <a:solidFill>
                   <a:srgbClr val="CCD3E0"/>
                 </a:solidFill>
@@ -25864,7 +25866,7 @@
               </a:lnSpc>
             </a:pPr>
             <a:r>
-              <a:rPr sz="1000" b="0" i="0">
+              <a:rPr sz="1200" b="0" i="0">
                 <a:solidFill>
                   <a:srgbClr val="CCD3E0"/>
                 </a:solidFill>
@@ -26025,7 +26027,7 @@
               </a:lnSpc>
             </a:pPr>
             <a:r>
-              <a:rPr sz="1000" b="0" i="0">
+              <a:rPr sz="1200" b="0" i="0">
                 <a:solidFill>
                   <a:srgbClr val="CCD3E0"/>
                 </a:solidFill>
@@ -26034,7 +26036,7 @@
               <a:t>日志+Trace+OTA</a:t>
             </a:r>
             <a:r>
-              <a:rPr sz="1000" b="0" i="0">
+              <a:rPr sz="1200" b="0" i="0">
                 <a:solidFill>
                   <a:srgbClr val="CCD3E0"/>
                 </a:solidFill>
@@ -26050,7 +26052,7 @@
               </a:lnSpc>
             </a:pPr>
             <a:r>
-              <a:rPr sz="1000" b="0" i="0">
+              <a:rPr sz="1200" b="0" i="0">
                 <a:solidFill>
                   <a:srgbClr val="CCD3E0"/>
                 </a:solidFill>
@@ -26059,7 +26061,7 @@
               <a:t>模型遥测+Runbook RAG</a:t>
             </a:r>
             <a:r>
-              <a:rPr sz="1000" b="0" i="0">
+              <a:rPr sz="1200" b="0" i="0">
                 <a:solidFill>
                   <a:srgbClr val="CCD3E0"/>
                 </a:solidFill>
@@ -26068,7 +26070,7 @@
               <a:t/>
             </a:r>
             <a:r>
-              <a:rPr sz="1000" b="0" i="0">
+              <a:rPr sz="1200" b="0" i="0">
                 <a:solidFill>
                   <a:srgbClr val="CCD3E0"/>
                 </a:solidFill>
@@ -26084,7 +26086,7 @@
               </a:lnSpc>
             </a:pPr>
             <a:r>
-              <a:rPr sz="1000" b="0" i="0">
+              <a:rPr sz="1200" b="0" i="0">
                 <a:solidFill>
                   <a:srgbClr val="CCD3E0"/>
                 </a:solidFill>
@@ -26245,7 +26247,7 @@
               </a:lnSpc>
             </a:pPr>
             <a:r>
-              <a:rPr sz="1000" b="0" i="0">
+              <a:rPr sz="1200" b="0" i="0">
                 <a:solidFill>
                   <a:srgbClr val="CCD3E0"/>
                 </a:solidFill>
@@ -26261,7 +26263,7 @@
               </a:lnSpc>
             </a:pPr>
             <a:r>
-              <a:rPr sz="1000" b="0" i="0">
+              <a:rPr sz="1200" b="0" i="0">
                 <a:solidFill>
                   <a:srgbClr val="CCD3E0"/>
                 </a:solidFill>
@@ -26270,7 +26272,7 @@
               <a:t>L0-L3 分级</a:t>
             </a:r>
             <a:r>
-              <a:rPr sz="1000" b="0" i="0">
+              <a:rPr sz="1200" b="0" i="0">
                 <a:solidFill>
                   <a:srgbClr val="CCD3E0"/>
                 </a:solidFill>
@@ -26286,7 +26288,7 @@
               </a:lnSpc>
             </a:pPr>
             <a:r>
-              <a:rPr sz="1000" b="0" i="0">
+              <a:rPr sz="1200" b="0" i="0">
                 <a:solidFill>
                   <a:srgbClr val="CCD3E0"/>
                 </a:solidFill>
@@ -26447,7 +26449,7 @@
               </a:lnSpc>
             </a:pPr>
             <a:r>
-              <a:rPr sz="1000" b="0" i="0">
+              <a:rPr sz="1200" b="0" i="0">
                 <a:solidFill>
                   <a:srgbClr val="CCD3E0"/>
                 </a:solidFill>
@@ -26463,7 +26465,7 @@
               </a:lnSpc>
             </a:pPr>
             <a:r>
-              <a:rPr sz="1000" b="0" i="0">
+              <a:rPr sz="1200" b="0" i="0">
                 <a:solidFill>
                   <a:srgbClr val="CCD3E0"/>
                 </a:solidFill>
@@ -26479,7 +26481,7 @@
               </a:lnSpc>
             </a:pPr>
             <a:r>
-              <a:rPr sz="1000" b="0" i="0">
+              <a:rPr sz="1200" b="0" i="0">
                 <a:solidFill>
                   <a:srgbClr val="CCD3E0"/>
                 </a:solidFill>
@@ -26562,7 +26564,7 @@
               </a:lnSpc>
             </a:pPr>
             <a:r>
-              <a:rPr sz="1100" b="1" i="0">
+              <a:rPr sz="1400" b="1" i="0">
                 <a:solidFill>
                   <a:srgbClr val="E85D26"/>
                 </a:solidFill>
@@ -26601,7 +26603,7 @@
               </a:lnSpc>
             </a:pPr>
             <a:r>
-              <a:rPr sz="1100" b="0" i="0">
+              <a:rPr sz="1300" b="0" i="0">
                 <a:solidFill>
                   <a:srgbClr val="14275C"/>
                 </a:solidFill>

</xml_diff>

<commit_message>
fix(ppt): align chapter names in TOC + replace INC-1001/1002 with INC-2001/2002
</commit_message>
<xml_diff>
--- a/docs/edge-aiops-submission.pptx
+++ b/docs/edge-aiops-submission.pptx
@@ -11488,7 +11488,7 @@
                 </a:solidFill>
                 <a:latin typeface="Times New Roman"/>
               </a:rPr>
-              <a:t>INC-1001</a:t>
+              <a:t>INC-2001</a:t>
             </a:r>
           </a:p>
         </p:txBody>
@@ -11571,7 +11571,7 @@
                 </a:solidFill>
                 <a:latin typeface="Times New Roman"/>
               </a:rPr>
-              <a:t>INC-1002</a:t>
+              <a:t>INC-2002</a:t>
             </a:r>
           </a:p>
         </p:txBody>
@@ -18441,7 +18441,7 @@
                 <a:ea typeface="微软雅黑" pitchFamily="34" charset="-122"/>
                 <a:cs typeface="微软雅黑" pitchFamily="34" charset="-120"/>
               </a:rPr>
-              <a:t>工具体系</a:t>
+              <a:t/>
             </a:r>
             <a:endParaRPr lang="zh-CN" altLang="en-US" sz="1250" dirty="0">
               <a:solidFill>
@@ -18581,7 +18581,7 @@
                 <a:ea typeface="微软雅黑" pitchFamily="34" charset="-122"/>
                 <a:cs typeface="微软雅黑" pitchFamily="34" charset="-120"/>
               </a:rPr>
-              <a:t>视频（如有</a:t>
+              <a:t/>
             </a:r>
             <a:r>
               <a:rPr lang="en-US" altLang="zh-CN" sz="1250" dirty="0">
@@ -18592,7 +18592,7 @@
                 <a:ea typeface="微软雅黑" pitchFamily="34" charset="-122"/>
                 <a:cs typeface="微软雅黑" pitchFamily="34" charset="-120"/>
               </a:rPr>
-              <a:t>）</a:t>
+              <a:t/>
             </a:r>
             <a:endParaRPr lang="en-US" altLang="zh-CN" sz="1250" dirty="0">
               <a:solidFill>

</xml_diff>